<commit_message>
Fix the two lines that were ON the slides, not just in the notes
The previous commit took 'you told me' out of the speaker notes and left it on
slide 2's takeaway and slide 3's accent strip - the two lines a room actually reads,
rather than the ones only the presenter sees. Caught by grepping the rendered deck
text instead of trusting the edit.

Slide 2 now states the change: the scope widened from one use case to three. Slide 3
states the blocker as a fact rather than a recollection: a decision nobody can see is
a decision nobody can sign off.
</commit_message>
<xml_diff>
--- a/presentation.pptx
+++ b/presentation.pptx
@@ -10439,7 +10439,7 @@
                 <a:ea typeface="Calibri" pitchFamily="34" charset="-122"/>
                 <a:cs typeface="Calibri" pitchFamily="34" charset="-120"/>
               </a:rPr>
-              <a:t>Same industry, same client, same lead use case. You told me to build all three — so I did.</a:t>
+              <a:t>Same industry, same client, same lead use case. The scope widened from one use case to three.</a:t>
             </a:r>
             <a:endParaRPr lang="en-US" sz="1050" dirty="0"/>
           </a:p>
@@ -12442,7 +12442,7 @@
                 <a:ea typeface="Calibri" pitchFamily="34" charset="-122"/>
                 <a:cs typeface="Calibri" pitchFamily="34" charset="-120"/>
               </a:rPr>
-              <a:t>You told me you don't trust AI because you can't see what it does.</a:t>
+              <a:t>A decision nobody can see is a decision nobody can sign off.</a:t>
             </a:r>
             <a:endParaRPr lang="en-US" sz="1700" dirty="0"/>
           </a:p>

</xml_diff>

<commit_message>
Rebuild the deck on the fixed deck_kit
No content change — the cover already passed an explicit kicker. Rebuilt so the
committed deck is the one the corrected kit produces, rather than one that happens
to look right because the build script overrode a bad default.

Cover reads AI CONSULTING CAPSTONE · ROUND 2, no company name anywhere, 18 slides,
notes on all 18, PDF re-exported.
</commit_message>
<xml_diff>
--- a/presentation.pptx
+++ b/presentation.pptx
@@ -3749,7 +3749,7 @@
               <a:buNone/>
             </a:pPr>
             <a:r>
-              <a:rPr lang="en-US" sz="1900" b="1" dirty="0">
+              <a:rPr lang="en-US" sz="1300" b="1" dirty="0">
                 <a:solidFill>
                   <a:srgbClr val="FFFFFF"/>
                 </a:solidFill>
@@ -5877,7 +5877,7 @@
               <a:buNone/>
             </a:pPr>
             <a:r>
-              <a:rPr lang="en-US" sz="1300" b="1" spc="200" kern="0" dirty="0">
+              <a:rPr lang="en-US" sz="1900" b="1" spc="200" kern="0" dirty="0">
                 <a:solidFill>
                   <a:srgbClr val="FFFFFF"/>
                 </a:solidFill>
@@ -5887,7 +5887,7 @@
               </a:rPr>
               <a:t>WHAT IT LEGITIMATELY SHOWS</a:t>
             </a:r>
-            <a:endParaRPr lang="en-US" sz="1300" dirty="0"/>
+            <a:endParaRPr lang="en-US" sz="1900" dirty="0"/>
           </a:p>
         </p:txBody>
       </p:sp>
@@ -6053,7 +6053,7 @@
               <a:buNone/>
             </a:pPr>
             <a:r>
-              <a:rPr lang="en-US" sz="1300" b="1" spc="200" kern="0" dirty="0">
+              <a:rPr lang="en-US" sz="1900" b="1" spc="200" kern="0" dirty="0">
                 <a:solidFill>
                   <a:srgbClr val="FFFFFF"/>
                 </a:solidFill>
@@ -6063,7 +6063,7 @@
               </a:rPr>
               <a:t>WHY IT IS NOT ACCURACY</a:t>
             </a:r>
-            <a:endParaRPr lang="en-US" sz="1300" dirty="0"/>
+            <a:endParaRPr lang="en-US" sz="1900" dirty="0"/>
           </a:p>
         </p:txBody>
       </p:sp>
@@ -10090,7 +10090,7 @@
               <a:buNone/>
             </a:pPr>
             <a:r>
-              <a:rPr lang="en-US" sz="1900" b="1" dirty="0">
+              <a:rPr lang="en-US" sz="1300" b="1" dirty="0">
                 <a:solidFill>
                   <a:srgbClr val="FFFFFF"/>
                 </a:solidFill>
@@ -16927,7 +16927,7 @@
               <a:buNone/>
             </a:pPr>
             <a:r>
-              <a:rPr lang="en-US" sz="1300" b="1" spc="200" kern="0" dirty="0">
+              <a:rPr lang="en-US" sz="1900" b="1" spc="200" kern="0" dirty="0">
                 <a:solidFill>
                   <a:srgbClr val="FFFFFF"/>
                 </a:solidFill>
@@ -16937,7 +16937,7 @@
               </a:rPr>
               <a:t>EU AI ACT</a:t>
             </a:r>
-            <a:endParaRPr lang="en-US" sz="1300" dirty="0"/>
+            <a:endParaRPr lang="en-US" sz="1900" dirty="0"/>
           </a:p>
         </p:txBody>
       </p:sp>
@@ -17103,7 +17103,7 @@
               <a:buNone/>
             </a:pPr>
             <a:r>
-              <a:rPr lang="en-US" sz="1300" b="1" spc="200" kern="0" dirty="0">
+              <a:rPr lang="en-US" sz="1900" b="1" spc="200" kern="0" dirty="0">
                 <a:solidFill>
                   <a:srgbClr val="FFFFFF"/>
                 </a:solidFill>
@@ -17113,7 +17113,7 @@
               </a:rPr>
               <a:t>GDPR</a:t>
             </a:r>
-            <a:endParaRPr lang="en-US" sz="1300" dirty="0"/>
+            <a:endParaRPr lang="en-US" sz="1900" dirty="0"/>
           </a:p>
         </p:txBody>
       </p:sp>

</xml_diff>